<commit_message>
Deck: the adoption slide covers all three paths - specialize, extend, tailor
Slide 9 now presents the full adoption story committees ask about:
specialize (type values, attribute overrides, subclasses), extend
(register, raw, variables), and tailor (profiles - a YAML subset,
narrowing only, machine-enforced). Annex references updated to match.
</commit_message>
<xml_diff>
--- a/presentations/lightweight-doc-tc154-dis-proposal.pptx
+++ b/presentations/lightweight-doc-tc154-dis-proposal.pptx
@@ -6633,7 +6633,7 @@
               </a:defRPr>
             </a:pPr>
             <a:r>
-              <a:t>Dialects arrive without ever forking the model</a:t>
+              <a:t>Adopt it three ways — none touch the base</a:t>
             </a:r>
           </a:p>
         </p:txBody>
@@ -6646,8 +6646,8 @@
         </p:nvSpPr>
         <p:spPr>
           <a:xfrm>
-            <a:off x="822960" y="1783080"/>
-            <a:ext cx="5029200" cy="365760"/>
+            <a:off x="502920" y="1783080"/>
+            <a:ext cx="3520440" cy="365760"/>
           </a:xfrm>
           <a:prstGeom prst="rect">
             <a:avLst/>
@@ -6661,7 +6661,7 @@
           <a:lstStyle/>
           <a:p>
             <a:pPr>
-              <a:defRPr sz="1600" b="1">
+              <a:defRPr sz="1500" b="1">
                 <a:solidFill>
                   <a:srgbClr val="2F6F82"/>
                 </a:solidFill>
@@ -6669,7 +6669,7 @@
               </a:defRPr>
             </a:pPr>
             <a:r>
-              <a:t>SPECIALIZE</a:t>
+              <a:t>SPECIALIZE — add</a:t>
             </a:r>
           </a:p>
         </p:txBody>
@@ -6682,8 +6682,8 @@
         </p:nvSpPr>
         <p:spPr>
           <a:xfrm>
-            <a:off x="822960" y="2212848"/>
-            <a:ext cx="5029200" cy="3108960"/>
+            <a:off x="502920" y="2212848"/>
+            <a:ext cx="3520440" cy="3291840"/>
           </a:xfrm>
           <a:prstGeom prst="rect">
             <a:avLst/>
@@ -6697,98 +6697,83 @@
           <a:lstStyle/>
           <a:p>
             <a:pPr>
-              <a:defRPr sz="1350" b="0">
+              <a:defRPr sz="1250" b="0">
                 <a:solidFill>
                   <a:srgbClr val="243647"/>
                 </a:solidFill>
               </a:defRPr>
             </a:pPr>
             <a:r>
-              <a:t>· Type values, not parallel classes —</a:t>
-            </a:r>
-          </a:p>
-          <a:p>
-            <a:pPr>
-              <a:defRPr sz="1350" b="0">
+              <a:t>· Type values, not parallel classes</a:t>
+            </a:r>
+          </a:p>
+          <a:p>
+            <a:pPr>
+              <a:defRPr sz="1250" b="0">
                 <a:solidFill>
                   <a:srgbClr val="243647"/>
                 </a:solidFill>
               </a:defRPr>
             </a:pPr>
             <a:r>
-              <a:t>  admonition kinds, list numeration,</a:t>
-            </a:r>
-          </a:p>
-          <a:p>
-            <a:pPr>
-              <a:defRPr sz="1350" b="0">
+              <a:t>· Attribute overrides: add,</a:t>
+            </a:r>
+          </a:p>
+          <a:p>
+            <a:pPr>
+              <a:defRPr sz="1250" b="0">
                 <a:solidFill>
                   <a:srgbClr val="243647"/>
                 </a:solidFill>
               </a:defRPr>
             </a:pPr>
             <a:r>
-              <a:t>  stem languages, document classes</a:t>
-            </a:r>
-          </a:p>
-          <a:p>
-            <a:pPr>
-              <a:defRPr sz="1350" b="0">
+              <a:t>  remove, retighten</a:t>
+            </a:r>
+          </a:p>
+          <a:p>
+            <a:pPr>
+              <a:defRPr sz="1250" b="0">
                 <a:solidFill>
                   <a:srgbClr val="243647"/>
                 </a:solidFill>
               </a:defRPr>
             </a:pPr>
             <a:r>
-              <a:t>· Attribute overrides: add, remove,</a:t>
-            </a:r>
-          </a:p>
-          <a:p>
-            <a:pPr>
-              <a:defRPr sz="1350" b="0">
+              <a:t>· Subclasses under the</a:t>
+            </a:r>
+          </a:p>
+          <a:p>
+            <a:pPr>
+              <a:defRPr sz="1250" b="0">
                 <a:solidFill>
                   <a:srgbClr val="243647"/>
                 </a:solidFill>
               </a:defRPr>
             </a:pPr>
             <a:r>
-              <a:t>  retighten (e.g. no hanging paragraphs)</a:t>
-            </a:r>
-          </a:p>
-          <a:p>
-            <a:pPr>
-              <a:defRPr sz="1350" b="0">
+              <a:t>  construct roots</a:t>
+            </a:r>
+          </a:p>
+          <a:p>
+            <a:pPr>
+              <a:defRPr sz="1250" b="0">
                 <a:solidFill>
                   <a:srgbClr val="243647"/>
                 </a:solidFill>
               </a:defRPr>
             </a:pPr>
-            <a:r>
-              <a:t>· Subclassing under the construct roots</a:t>
-            </a:r>
-          </a:p>
-          <a:p>
-            <a:pPr>
-              <a:defRPr sz="1350" b="0">
+          </a:p>
+          <a:p>
+            <a:pPr>
+              <a:defRPr sz="1250" b="0">
                 <a:solidFill>
                   <a:srgbClr val="243647"/>
                 </a:solidFill>
               </a:defRPr>
             </a:pPr>
             <a:r>
-              <a:t>· Constraint specialization:</a:t>
-            </a:r>
-          </a:p>
-          <a:p>
-            <a:pPr>
-              <a:defRPr sz="1350" b="0">
-                <a:solidFill>
-                  <a:srgbClr val="243647"/>
-                </a:solidFill>
-              </a:defRPr>
-            </a:pPr>
-            <a:r>
-              <a:t>  PureTextElement recursion guarantees</a:t>
+              <a:t>Annex B</a:t>
             </a:r>
           </a:p>
         </p:txBody>
@@ -6801,8 +6786,8 @@
         </p:nvSpPr>
         <p:spPr>
           <a:xfrm>
-            <a:off x="6400800" y="1783080"/>
-            <a:ext cx="4937760" cy="365760"/>
+            <a:off x="4315968" y="1783080"/>
+            <a:ext cx="3520440" cy="365760"/>
           </a:xfrm>
           <a:prstGeom prst="rect">
             <a:avLst/>
@@ -6816,7 +6801,7 @@
           <a:lstStyle/>
           <a:p>
             <a:pPr>
-              <a:defRPr sz="1600" b="1">
+              <a:defRPr sz="1500" b="1">
                 <a:solidFill>
                   <a:srgbClr val="B85A2A"/>
                 </a:solidFill>
@@ -6824,7 +6809,7 @@
               </a:defRPr>
             </a:pPr>
             <a:r>
-              <a:t>EXTEND</a:t>
+              <a:t>EXTEND — carry</a:t>
             </a:r>
           </a:p>
         </p:txBody>
@@ -6837,8 +6822,8 @@
         </p:nvSpPr>
         <p:spPr>
           <a:xfrm>
-            <a:off x="6400800" y="2212848"/>
-            <a:ext cx="4937760" cy="3200400"/>
+            <a:off x="4315968" y="2212848"/>
+            <a:ext cx="3520440" cy="3291840"/>
           </a:xfrm>
           <a:prstGeom prst="rect">
             <a:avLst/>
@@ -6852,110 +6837,83 @@
           <a:lstStyle/>
           <a:p>
             <a:pPr>
-              <a:defRPr sz="1350" b="0">
+              <a:defRPr sz="1250" b="0">
                 <a:solidFill>
                   <a:srgbClr val="243647"/>
                 </a:solidFill>
               </a:defRPr>
             </a:pPr>
             <a:r>
-              <a:t>· Attribute register: open key-value</a:t>
-            </a:r>
-          </a:p>
-          <a:p>
-            <a:pPr>
-              <a:defRPr sz="1350" b="0">
+              <a:t>· Attribute register: dialect</a:t>
+            </a:r>
+          </a:p>
+          <a:p>
+            <a:pPr>
+              <a:defRPr sz="1250" b="0">
                 <a:solidFill>
                   <a:srgbClr val="243647"/>
                 </a:solidFill>
               </a:defRPr>
             </a:pPr>
             <a:r>
-              <a:t>  entries on any construct — dialect</a:t>
-            </a:r>
-          </a:p>
-          <a:p>
-            <a:pPr>
-              <a:defRPr sz="1350" b="0">
+              <a:t>  keys on any construct,</a:t>
+            </a:r>
+          </a:p>
+          <a:p>
+            <a:pPr>
+              <a:defRPr sz="1250" b="0">
                 <a:solidFill>
                   <a:srgbClr val="243647"/>
                 </a:solidFill>
               </a:defRPr>
             </a:pPr>
             <a:r>
-              <a:t>  keys (checkbox, option), no model change</a:t>
-            </a:r>
-          </a:p>
-          <a:p>
-            <a:pPr>
-              <a:defRPr sz="1350" b="0">
+              <a:t>  zero model change</a:t>
+            </a:r>
+          </a:p>
+          <a:p>
+            <a:pPr>
+              <a:defRPr sz="1250" b="0">
                 <a:solidFill>
                   <a:srgbClr val="243647"/>
                 </a:solidFill>
               </a:defRPr>
             </a:pPr>
             <a:r>
-              <a:t>· Raw stays lossless: FormattedString,</a:t>
-            </a:r>
-          </a:p>
-          <a:p>
-            <a:pPr>
-              <a:defRPr sz="1350" b="0">
+              <a:t>· Raw, variables, unknown</a:t>
+            </a:r>
+          </a:p>
+          <a:p>
+            <a:pPr>
+              <a:defRPr sz="1250" b="0">
                 <a:solidFill>
                   <a:srgbClr val="243647"/>
                 </a:solidFill>
               </a:defRPr>
             </a:pPr>
             <a:r>
-              <a:t>  format-qualified blocks</a:t>
-            </a:r>
-          </a:p>
-          <a:p>
-            <a:pPr>
-              <a:defRPr sz="1350" b="0">
+              <a:t>  directives — all lossless</a:t>
+            </a:r>
+          </a:p>
+          <a:p>
+            <a:pPr>
+              <a:defRPr sz="1250" b="0">
                 <a:solidFill>
                   <a:srgbClr val="243647"/>
                 </a:solidFill>
               </a:defRPr>
             </a:pPr>
-            <a:r>
-              <a:t>· Unknown directives (all of Sphinx)</a:t>
-            </a:r>
-          </a:p>
-          <a:p>
-            <a:pPr>
-              <a:defRPr sz="1350" b="0">
+          </a:p>
+          <a:p>
+            <a:pPr>
+              <a:defRPr sz="1250" b="0">
                 <a:solidFill>
                   <a:srgbClr val="243647"/>
                 </a:solidFill>
               </a:defRPr>
             </a:pPr>
             <a:r>
-              <a:t>  decompose into register + relaxed content</a:t>
-            </a:r>
-          </a:p>
-          <a:p>
-            <a:pPr>
-              <a:defRPr sz="1350" b="0">
-                <a:solidFill>
-                  <a:srgbClr val="243647"/>
-                </a:solidFill>
-              </a:defRPr>
-            </a:pPr>
-            <a:r>
-              <a:t>· A document is a block: whole documents</a:t>
-            </a:r>
-          </a:p>
-          <a:p>
-            <a:pPr>
-              <a:defRPr sz="1350" b="0">
-                <a:solidFill>
-                  <a:srgbClr val="243647"/>
-                </a:solidFill>
-              </a:defRPr>
-            </a:pPr>
-            <a:r>
-              <a:t>  compose as child content</a:t>
+              <a:t>Annex C</a:t>
             </a:r>
           </a:p>
         </p:txBody>
@@ -6968,6 +6926,158 @@
         </p:nvSpPr>
         <p:spPr>
           <a:xfrm>
+            <a:off x="8138160" y="1783080"/>
+            <a:ext cx="3566160" cy="365760"/>
+          </a:xfrm>
+          <a:prstGeom prst="rect">
+            <a:avLst/>
+          </a:prstGeom>
+          <a:noFill/>
+        </p:spPr>
+        <p:txBody>
+          <a:bodyPr wrap="square">
+            <a:spAutoFit/>
+          </a:bodyPr>
+          <a:lstStyle/>
+          <a:p>
+            <a:pPr>
+              <a:defRPr sz="1500" b="1">
+                <a:solidFill>
+                  <a:srgbClr val="2D6A4F"/>
+                </a:solidFill>
+                <a:latin typeface="Courier New"/>
+              </a:defRPr>
+            </a:pPr>
+            <a:r>
+              <a:t>TAILOR — subtract</a:t>
+            </a:r>
+          </a:p>
+        </p:txBody>
+      </p:sp>
+      <p:sp>
+        <p:nvSpPr>
+          <p:cNvPr id="10" name="TextBox 9"/>
+          <p:cNvSpPr txBox="1"/>
+          <p:nvPr/>
+        </p:nvSpPr>
+        <p:spPr>
+          <a:xfrm>
+            <a:off x="8138160" y="2212848"/>
+            <a:ext cx="3566160" cy="3291840"/>
+          </a:xfrm>
+          <a:prstGeom prst="rect">
+            <a:avLst/>
+          </a:prstGeom>
+          <a:noFill/>
+        </p:spPr>
+        <p:txBody>
+          <a:bodyPr wrap="square">
+            <a:spAutoFit/>
+          </a:bodyPr>
+          <a:lstStyle/>
+          <a:p>
+            <a:pPr>
+              <a:defRPr sz="1250" b="0">
+                <a:solidFill>
+                  <a:srgbClr val="243647"/>
+                </a:solidFill>
+              </a:defRPr>
+            </a:pPr>
+            <a:r>
+              <a:t>· Profiles: ~20 lines of YAML</a:t>
+            </a:r>
+          </a:p>
+          <a:p>
+            <a:pPr>
+              <a:defRPr sz="1250" b="0">
+                <a:solidFill>
+                  <a:srgbClr val="243647"/>
+                </a:solidFill>
+              </a:defRPr>
+            </a:pPr>
+            <a:r>
+              <a:t>  declare your subset</a:t>
+            </a:r>
+          </a:p>
+          <a:p>
+            <a:pPr>
+              <a:defRPr sz="1250" b="0">
+                <a:solidFill>
+                  <a:srgbClr val="243647"/>
+                </a:solidFill>
+              </a:defRPr>
+            </a:pPr>
+            <a:r>
+              <a:t>· Narrowing only — the machine</a:t>
+            </a:r>
+          </a:p>
+          <a:p>
+            <a:pPr>
+              <a:defRPr sz="1250" b="0">
+                <a:solidFill>
+                  <a:srgbClr val="243647"/>
+                </a:solidFill>
+              </a:defRPr>
+            </a:pPr>
+            <a:r>
+              <a:t>  rejects any widening</a:t>
+            </a:r>
+          </a:p>
+          <a:p>
+            <a:pPr>
+              <a:defRPr sz="1250" b="0">
+                <a:solidFill>
+                  <a:srgbClr val="243647"/>
+                </a:solidFill>
+              </a:defRPr>
+            </a:pPr>
+            <a:r>
+              <a:t>· A profile document is always</a:t>
+            </a:r>
+          </a:p>
+          <a:p>
+            <a:pPr>
+              <a:defRPr sz="1250" b="0">
+                <a:solidFill>
+                  <a:srgbClr val="243647"/>
+                </a:solidFill>
+              </a:defRPr>
+            </a:pPr>
+            <a:r>
+              <a:t>  a valid base document</a:t>
+            </a:r>
+          </a:p>
+          <a:p>
+            <a:pPr>
+              <a:defRPr sz="1250" b="0">
+                <a:solidFill>
+                  <a:srgbClr val="243647"/>
+                </a:solidFill>
+              </a:defRPr>
+            </a:pPr>
+          </a:p>
+          <a:p>
+            <a:pPr>
+              <a:defRPr sz="1250" b="0">
+                <a:solidFill>
+                  <a:srgbClr val="243647"/>
+                </a:solidFill>
+              </a:defRPr>
+            </a:pPr>
+            <a:r>
+              <a:t>Clause 4 + registry</a:t>
+            </a:r>
+          </a:p>
+        </p:txBody>
+      </p:sp>
+      <p:sp>
+        <p:nvSpPr>
+          <p:cNvPr id="11" name="TextBox 10"/>
+          <p:cNvSpPr txBox="1"/>
+          <p:nvPr/>
+        </p:nvSpPr>
+        <p:spPr>
+          <a:xfrm>
             <a:off x="822960" y="5715000"/>
             <a:ext cx="10515600" cy="685800"/>
           </a:xfrm>
@@ -6990,14 +7100,14 @@
               </a:defRPr>
             </a:pPr>
             <a:r>
-              <a:t>Open-closed by construction: the basis is defined once and never modified — only specialized upon.</a:t>
-            </a:r>
-          </a:p>
-        </p:txBody>
-      </p:sp>
-      <p:sp>
-        <p:nvSpPr>
-          <p:cNvPr id="10" name="TextBox 9"/>
+              <a:t>Open-closed by construction: the basis is never modified — only specialized, extended, or profiled.</a:t>
+            </a:r>
+          </a:p>
+        </p:txBody>
+      </p:sp>
+      <p:sp>
+        <p:nvSpPr>
+          <p:cNvPr id="12" name="TextBox 11"/>
           <p:cNvSpPr txBox="1"/>
           <p:nvPr/>
         </p:nvSpPr>

</xml_diff>